<commit_message>
feat: update Lab1 presentation slides
</commit_message>
<xml_diff>
--- a/Lab1/sc2001_lab1_slides.pptx
+++ b/Lab1/sc2001_lab1_slides.pptx
@@ -1554,7 +1554,7 @@
         </p:nvSpPr>
         <p:spPr>
           <a:xfrm>
-            <a:off x="548640" y="411480"/>
+            <a:off x="548640" y="219458"/>
             <a:ext cx="10972800" cy="640080"/>
           </a:xfrm>
           <a:prstGeom prst="rect">
@@ -1593,8 +1593,8 @@
         </p:nvSpPr>
         <p:spPr>
           <a:xfrm>
-            <a:off x="548640" y="1371600"/>
-            <a:ext cx="5486400" cy="3108960"/>
+            <a:off x="548639" y="1165706"/>
+            <a:ext cx="6191207" cy="4754880"/>
           </a:xfrm>
           <a:prstGeom prst="rect">
             <a:avLst/>
@@ -1622,7 +1622,7 @@
                 <a:ea typeface="Calibri" pitchFamily="34" charset="-122"/>
                 <a:cs typeface="Calibri" pitchFamily="34" charset="-120"/>
               </a:rPr>
-              <a:t>Merge sort recurses all the way down to subarrays of size 1 — at very small sizes, function-call and merge overhead dominates the actual sorting work.</a:t>
+              <a:t>Quick recap: Merge sort recursively splits array all the way down to subarrays of size 1 — level by level merge all arrays back in sorted manner. At very small sizes, function-call and merge overhead takes up most of the time complexity.</a:t>
             </a:r>
             <a:endParaRPr lang="en-US" dirty="0"/>
           </a:p>
@@ -1643,16 +1643,39 @@
                 <a:ea typeface="Calibri" pitchFamily="34" charset="-122"/>
                 <a:cs typeface="Calibri" pitchFamily="34" charset="-120"/>
               </a:rPr>
-              <a:t>Insertion sort has near-zero overhead per element, and is efficient exactly where merge sort is wasteful: small arrays.</a:t>
-            </a:r>
-            <a:endParaRPr lang="en-US" dirty="0"/>
-          </a:p>
-          <a:p>
-            <a:pPr marL="342900" indent="-342900">
+              <a:t>Insertion sort, typically O(n^2) complexity is efficient exactly where merge sort is wasteful, i.e. small arrays.</a:t>
+            </a:r>
+          </a:p>
+          <a:p>
+            <a:pPr>
               <a:spcAft>
                 <a:spcPts val="1400"/>
               </a:spcAft>
               <a:buSzPct val="100000"/>
+            </a:pPr>
+            <a:r>
+              <a:rPr lang="en-US" dirty="0">
+                <a:solidFill>
+                  <a:srgbClr val="1A1A2E"/>
+                </a:solidFill>
+                <a:latin typeface="Calibri" pitchFamily="34" charset="0"/>
+                <a:ea typeface="Calibri" pitchFamily="34" charset="-122"/>
+                <a:cs typeface="Calibri" pitchFamily="34" charset="-120"/>
+              </a:rPr>
+              <a:t>	Reasons: </a:t>
+            </a:r>
+            <a:r>
+              <a:rPr lang="en-IN" dirty="0"/>
+              <a:t>simple loops, no recursive calls, doesn’t create 	and merge temporary subarrays and accesses nearby 	memory locations, giving us better time complex. </a:t>
+            </a:r>
+          </a:p>
+          <a:p>
+            <a:pPr marL="285750" indent="-285750">
+              <a:spcAft>
+                <a:spcPts val="1400"/>
+              </a:spcAft>
+              <a:buSzPct val="100000"/>
+              <a:buFont typeface="Arial" panose="020B0604020202020204" pitchFamily="34" charset="0"/>
               <a:buChar char="•"/>
             </a:pPr>
             <a:r>
@@ -1775,7 +1798,7 @@
         </p:nvSpPr>
         <p:spPr>
           <a:xfrm>
-            <a:off x="7273074" y="1843185"/>
+            <a:off x="7324444" y="1884281"/>
             <a:ext cx="1828800" cy="621792"/>
           </a:xfrm>
           <a:prstGeom prst="rect">
@@ -1950,7 +1973,7 @@
         </p:nvSpPr>
         <p:spPr>
           <a:xfrm>
-            <a:off x="548640" y="4892040"/>
+            <a:off x="548640" y="5189987"/>
             <a:ext cx="11064240" cy="1234440"/>
           </a:xfrm>
           <a:prstGeom prst="roundRect">
@@ -1984,7 +2007,7 @@
         </p:nvSpPr>
         <p:spPr>
           <a:xfrm>
-            <a:off x="822960" y="5074920"/>
+            <a:off x="822960" y="5372867"/>
             <a:ext cx="10515600" cy="914400"/>
           </a:xfrm>
           <a:prstGeom prst="rect">
@@ -2042,7 +2065,7 @@
                 <a:ea typeface="Courier New" pitchFamily="34" charset="-122"/>
                 <a:cs typeface="Courier New" pitchFamily="34" charset="-120"/>
               </a:rPr>
-              <a:t>else:  split, hybrid_sort() on both halves, then merge()</a:t>
+              <a:t>else:  split array, hybrid_sort() on both halves, then merge()</a:t>
             </a:r>
             <a:endParaRPr lang="en-US" sz="1350" dirty="0"/>
           </a:p>
@@ -2478,7 +2501,7 @@
                 <a:ea typeface="Calibri" pitchFamily="34" charset="-122"/>
                 <a:cs typeface="Calibri" pitchFamily="34" charset="-120"/>
               </a:rPr>
-              <a:t>Same array reused across every S value tested at a given n — isolates S as the only variable changing between runs.</a:t>
+              <a:t>Same array reused across every S value tested at a given n — S is the only variable changing between runs, not the input data</a:t>
             </a:r>
             <a:endParaRPr lang="en-US" dirty="0"/>
           </a:p>
@@ -2519,7 +2542,7 @@
                 <a:ea typeface="Calibri" pitchFamily="34" charset="-122"/>
                 <a:cs typeface="Calibri" pitchFamily="34" charset="-120"/>
               </a:rPr>
-              <a:t>Correctness is asserted against Python's sorted() on every single run — a wrong result fails loudly rather than silently producing bad data.</a:t>
+              <a:t>Correctness is asserted against Python’s built in sorted() on every single run — a wrong result raises an error instead of entering bad data into the system.</a:t>
             </a:r>
             <a:endParaRPr lang="en-US" dirty="0"/>
           </a:p>

</xml_diff>